<commit_message>
Phase 13: AI features + email infrastructure
</commit_message>
<xml_diff>
--- a/ArtistOS-Pitch-Deck.pptx
+++ b/ArtistOS-Pitch-Deck.pptx
@@ -2203,7 +2203,7 @@
                 <a:ea typeface="Calibri" pitchFamily="34" charset="-122"/>
                 <a:cs typeface="Calibri" pitchFamily="34" charset="-120"/>
               </a:rPr>
-              <a:t>Stripe payment integration, mobile-responsive polish</a:t>
+              <a:t>Beta launch, 100 artist onboarding, mobile-responsive polish</a:t>
             </a:r>
             <a:endParaRPr lang="en-US" sz="1300" dirty="0"/>
           </a:p>
@@ -3362,7 +3362,7 @@
                 <a:ea typeface="Calibri" pitchFamily="34" charset="-122"/>
                 <a:cs typeface="Calibri" pitchFamily="34" charset="-120"/>
               </a:rPr>
-              <a:t>larrywade.art@gmail.com</a:t>
+              <a:t>larry@synergysourceadvisors.com</a:t>
             </a:r>
             <a:endParaRPr lang="en-US" sz="1400" dirty="0"/>
           </a:p>
@@ -4715,7 +4715,7 @@
                 <a:ea typeface="Georgia" pitchFamily="34" charset="-122"/>
                 <a:cs typeface="Georgia" pitchFamily="34" charset="-120"/>
               </a:rPr>
-              <a:t>📊  Analyze</a:t>
+              <a:t>🚀  Subscribe &amp; Grow</a:t>
             </a:r>
             <a:endParaRPr lang="en-US" sz="1500" dirty="0"/>
           </a:p>
@@ -4754,7 +4754,7 @@
                 <a:ea typeface="Calibri" pitchFamily="34" charset="-122"/>
                 <a:cs typeface="Calibri" pitchFamily="34" charset="-120"/>
               </a:rPr>
-              <a:t>Market Analytics, Emerging Artists, Marketplace</a:t>
+              <a:t>Stripe Payments, Plan Gating, Onboarding Wizard, Billing Portal</a:t>
             </a:r>
             <a:endParaRPr lang="en-US" sz="1100" dirty="0"/>
           </a:p>
@@ -5207,7 +5207,7 @@
                 <a:ea typeface="Georgia" pitchFamily="34" charset="-122"/>
                 <a:cs typeface="Georgia" pitchFamily="34" charset="-120"/>
               </a:rPr>
-              <a:t>Exhibition Planner</a:t>
+              <a:t>Stripe Subscription Payments</a:t>
             </a:r>
             <a:endParaRPr lang="en-US" sz="1600" dirty="0"/>
           </a:p>
@@ -5249,7 +5249,7 @@
                 <a:ea typeface="Calibri" pitchFamily="34" charset="-122"/>
                 <a:cs typeface="Calibri" pitchFamily="34" charset="-120"/>
               </a:rPr>
-              <a:t>Plan shows with interactive checklists, timelines, and artwork selection tools.</a:t>
+              <a:t>Built-in Stripe checkout, tiered plans with feature gating, billing portal, and webhook-driven plan management.</a:t>
             </a:r>
             <a:endParaRPr lang="en-US" sz="1200" dirty="0"/>
           </a:p>
@@ -5288,7 +5288,7 @@
                 <a:ea typeface="Calibri" pitchFamily="34" charset="-122"/>
                 <a:cs typeface="Calibri" pitchFamily="34" charset="-120"/>
               </a:rPr>
-              <a:t>Plus 19 more features including Viewing Rooms, CRM, Social Scheduler, Consignment Tracker...</a:t>
+              <a:t>Plus 26 more features including Viewing Rooms, CRM, Social Scheduler, Onboarding Wizard, Exhibition Planner...</a:t>
             </a:r>
             <a:endParaRPr lang="en-US" sz="1000" dirty="0"/>
           </a:p>
@@ -7983,7 +7983,7 @@
                 <a:ea typeface="Calibri" pitchFamily="34" charset="-122"/>
                 <a:cs typeface="Calibri" pitchFamily="34" charset="-120"/>
               </a:rPr>
-              <a:t>Expense Tracking</a:t>
+              <a:t>Built-in Payments</a:t>
             </a:r>
             <a:endParaRPr lang="en-US" sz="950" dirty="0"/>
           </a:p>
@@ -8239,7 +8239,7 @@
                 <a:ea typeface="Calibri" pitchFamily="34" charset="-122"/>
                 <a:cs typeface="Calibri" pitchFamily="34" charset="-120"/>
               </a:rPr>
-              <a:t>Public Marketplace</a:t>
+              <a:t>Expense Tracking</a:t>
             </a:r>
             <a:endParaRPr lang="en-US" sz="950" dirty="0"/>
           </a:p>
@@ -8495,7 +8495,7 @@
                 <a:ea typeface="Calibri" pitchFamily="34" charset="-122"/>
                 <a:cs typeface="Calibri" pitchFamily="34" charset="-120"/>
               </a:rPr>
-              <a:t>Target User</a:t>
+              <a:t>Public Marketplace</a:t>
             </a:r>
             <a:endParaRPr lang="en-US" sz="950" dirty="0"/>
           </a:p>
@@ -8551,15 +8551,15 @@
               <a:buNone/>
             </a:pPr>
             <a:r>
-              <a:rPr lang="en-US" sz="950" dirty="0">
-                <a:solidFill>
-                  <a:srgbClr val="0E0C0A"/>
+              <a:rPr lang="en-US" sz="950" b="1" dirty="0">
+                <a:solidFill>
+                  <a:srgbClr val="2D6A4F"/>
                 </a:solidFill>
                 <a:latin typeface="Calibri" pitchFamily="34" charset="0"/>
                 <a:ea typeface="Calibri" pitchFamily="34" charset="-122"/>
                 <a:cs typeface="Calibri" pitchFamily="34" charset="-120"/>
               </a:rPr>
-              <a:t>Artists</a:t>
+              <a:t>Yes</a:t>
             </a:r>
             <a:endParaRPr lang="en-US" sz="950" dirty="0"/>
           </a:p>
@@ -8615,15 +8615,15 @@
               <a:buNone/>
             </a:pPr>
             <a:r>
-              <a:rPr lang="en-US" sz="950" dirty="0">
-                <a:solidFill>
-                  <a:srgbClr val="0E0C0A"/>
+              <a:rPr lang="en-US" sz="950" b="1" dirty="0">
+                <a:solidFill>
+                  <a:srgbClr val="9B2226"/>
                 </a:solidFill>
                 <a:latin typeface="Calibri" pitchFamily="34" charset="0"/>
                 <a:ea typeface="Calibri" pitchFamily="34" charset="-122"/>
                 <a:cs typeface="Calibri" pitchFamily="34" charset="-120"/>
               </a:rPr>
-              <a:t>Galleries</a:t>
+              <a:t>No</a:t>
             </a:r>
             <a:endParaRPr lang="en-US" sz="950" dirty="0"/>
           </a:p>
@@ -8663,6 +8663,262 @@
         <p:spPr>
           <a:xfrm>
             <a:off x="7955280" y="5230368"/>
+            <a:ext cx="2286000" cy="329184"/>
+          </a:xfrm>
+          <a:prstGeom prst="rect">
+            <a:avLst/>
+          </a:prstGeom>
+          <a:noFill/>
+          <a:ln/>
+        </p:spPr>
+        <p:txBody>
+          <a:bodyPr wrap="square" lIns="0" tIns="0" rIns="0" bIns="0" rtlCol="0" anchor="ctr"/>
+          <a:lstStyle/>
+          <a:p>
+            <a:pPr algn="ctr" indent="0" marL="0">
+              <a:buNone/>
+            </a:pPr>
+            <a:r>
+              <a:rPr lang="en-US" sz="950" b="1" dirty="0">
+                <a:solidFill>
+                  <a:srgbClr val="9B2226"/>
+                </a:solidFill>
+                <a:latin typeface="Calibri" pitchFamily="34" charset="0"/>
+                <a:ea typeface="Calibri" pitchFamily="34" charset="-122"/>
+                <a:cs typeface="Calibri" pitchFamily="34" charset="-120"/>
+              </a:rPr>
+              <a:t>No</a:t>
+            </a:r>
+            <a:endParaRPr lang="en-US" sz="950" dirty="0"/>
+          </a:p>
+        </p:txBody>
+      </p:sp>
+      <p:sp>
+        <p:nvSpPr>
+          <p:cNvPr id="107" name="Shape 105"/>
+          <p:cNvSpPr/>
+          <p:nvPr/>
+        </p:nvSpPr>
+        <p:spPr>
+          <a:xfrm>
+            <a:off x="822960" y="5559552"/>
+            <a:ext cx="2560320" cy="329184"/>
+          </a:xfrm>
+          <a:prstGeom prst="rect">
+            <a:avLst/>
+          </a:prstGeom>
+          <a:solidFill>
+            <a:srgbClr val="FFFFFF"/>
+          </a:solidFill>
+          <a:ln w="3175">
+            <a:solidFill>
+              <a:srgbClr val="E8E2DA"/>
+            </a:solidFill>
+            <a:prstDash val="solid"/>
+          </a:ln>
+        </p:spPr>
+      </p:sp>
+      <p:sp>
+        <p:nvSpPr>
+          <p:cNvPr id="108" name="Text 106"/>
+          <p:cNvSpPr/>
+          <p:nvPr/>
+        </p:nvSpPr>
+        <p:spPr>
+          <a:xfrm>
+            <a:off x="822960" y="5559552"/>
+            <a:ext cx="2560320" cy="329184"/>
+          </a:xfrm>
+          <a:prstGeom prst="rect">
+            <a:avLst/>
+          </a:prstGeom>
+          <a:noFill/>
+          <a:ln/>
+        </p:spPr>
+        <p:txBody>
+          <a:bodyPr wrap="square" lIns="0" tIns="101600" rIns="0" bIns="0" rtlCol="0" anchor="ctr"/>
+          <a:lstStyle/>
+          <a:p>
+            <a:pPr algn="l" indent="0" marL="0">
+              <a:buNone/>
+            </a:pPr>
+            <a:r>
+              <a:rPr lang="en-US" sz="950" dirty="0">
+                <a:solidFill>
+                  <a:srgbClr val="0E0C0A"/>
+                </a:solidFill>
+                <a:latin typeface="Calibri" pitchFamily="34" charset="0"/>
+                <a:ea typeface="Calibri" pitchFamily="34" charset="-122"/>
+                <a:cs typeface="Calibri" pitchFamily="34" charset="-120"/>
+              </a:rPr>
+              <a:t>Target User</a:t>
+            </a:r>
+            <a:endParaRPr lang="en-US" sz="950" dirty="0"/>
+          </a:p>
+        </p:txBody>
+      </p:sp>
+      <p:sp>
+        <p:nvSpPr>
+          <p:cNvPr id="109" name="Shape 107"/>
+          <p:cNvSpPr/>
+          <p:nvPr/>
+        </p:nvSpPr>
+        <p:spPr>
+          <a:xfrm>
+            <a:off x="3383280" y="5559552"/>
+            <a:ext cx="2286000" cy="329184"/>
+          </a:xfrm>
+          <a:prstGeom prst="rect">
+            <a:avLst/>
+          </a:prstGeom>
+          <a:solidFill>
+            <a:srgbClr val="FFFFFF"/>
+          </a:solidFill>
+          <a:ln w="3175">
+            <a:solidFill>
+              <a:srgbClr val="E8E2DA"/>
+            </a:solidFill>
+            <a:prstDash val="solid"/>
+          </a:ln>
+        </p:spPr>
+      </p:sp>
+      <p:sp>
+        <p:nvSpPr>
+          <p:cNvPr id="110" name="Text 108"/>
+          <p:cNvSpPr/>
+          <p:nvPr/>
+        </p:nvSpPr>
+        <p:spPr>
+          <a:xfrm>
+            <a:off x="3383280" y="5559552"/>
+            <a:ext cx="2286000" cy="329184"/>
+          </a:xfrm>
+          <a:prstGeom prst="rect">
+            <a:avLst/>
+          </a:prstGeom>
+          <a:noFill/>
+          <a:ln/>
+        </p:spPr>
+        <p:txBody>
+          <a:bodyPr wrap="square" lIns="0" tIns="0" rIns="0" bIns="0" rtlCol="0" anchor="ctr"/>
+          <a:lstStyle/>
+          <a:p>
+            <a:pPr algn="ctr" indent="0" marL="0">
+              <a:buNone/>
+            </a:pPr>
+            <a:r>
+              <a:rPr lang="en-US" sz="950" dirty="0">
+                <a:solidFill>
+                  <a:srgbClr val="0E0C0A"/>
+                </a:solidFill>
+                <a:latin typeface="Calibri" pitchFamily="34" charset="0"/>
+                <a:ea typeface="Calibri" pitchFamily="34" charset="-122"/>
+                <a:cs typeface="Calibri" pitchFamily="34" charset="-120"/>
+              </a:rPr>
+              <a:t>Artists</a:t>
+            </a:r>
+            <a:endParaRPr lang="en-US" sz="950" dirty="0"/>
+          </a:p>
+        </p:txBody>
+      </p:sp>
+      <p:sp>
+        <p:nvSpPr>
+          <p:cNvPr id="111" name="Shape 109"/>
+          <p:cNvSpPr/>
+          <p:nvPr/>
+        </p:nvSpPr>
+        <p:spPr>
+          <a:xfrm>
+            <a:off x="5669280" y="5559552"/>
+            <a:ext cx="2286000" cy="329184"/>
+          </a:xfrm>
+          <a:prstGeom prst="rect">
+            <a:avLst/>
+          </a:prstGeom>
+          <a:solidFill>
+            <a:srgbClr val="FFFFFF"/>
+          </a:solidFill>
+          <a:ln w="3175">
+            <a:solidFill>
+              <a:srgbClr val="E8E2DA"/>
+            </a:solidFill>
+            <a:prstDash val="solid"/>
+          </a:ln>
+        </p:spPr>
+      </p:sp>
+      <p:sp>
+        <p:nvSpPr>
+          <p:cNvPr id="112" name="Text 110"/>
+          <p:cNvSpPr/>
+          <p:nvPr/>
+        </p:nvSpPr>
+        <p:spPr>
+          <a:xfrm>
+            <a:off x="5669280" y="5559552"/>
+            <a:ext cx="2286000" cy="329184"/>
+          </a:xfrm>
+          <a:prstGeom prst="rect">
+            <a:avLst/>
+          </a:prstGeom>
+          <a:noFill/>
+          <a:ln/>
+        </p:spPr>
+        <p:txBody>
+          <a:bodyPr wrap="square" lIns="0" tIns="0" rIns="0" bIns="0" rtlCol="0" anchor="ctr"/>
+          <a:lstStyle/>
+          <a:p>
+            <a:pPr algn="ctr" indent="0" marL="0">
+              <a:buNone/>
+            </a:pPr>
+            <a:r>
+              <a:rPr lang="en-US" sz="950" dirty="0">
+                <a:solidFill>
+                  <a:srgbClr val="0E0C0A"/>
+                </a:solidFill>
+                <a:latin typeface="Calibri" pitchFamily="34" charset="0"/>
+                <a:ea typeface="Calibri" pitchFamily="34" charset="-122"/>
+                <a:cs typeface="Calibri" pitchFamily="34" charset="-120"/>
+              </a:rPr>
+              <a:t>Galleries</a:t>
+            </a:r>
+            <a:endParaRPr lang="en-US" sz="950" dirty="0"/>
+          </a:p>
+        </p:txBody>
+      </p:sp>
+      <p:sp>
+        <p:nvSpPr>
+          <p:cNvPr id="113" name="Shape 111"/>
+          <p:cNvSpPr/>
+          <p:nvPr/>
+        </p:nvSpPr>
+        <p:spPr>
+          <a:xfrm>
+            <a:off x="7955280" y="5559552"/>
+            <a:ext cx="2286000" cy="329184"/>
+          </a:xfrm>
+          <a:prstGeom prst="rect">
+            <a:avLst/>
+          </a:prstGeom>
+          <a:solidFill>
+            <a:srgbClr val="FFFFFF"/>
+          </a:solidFill>
+          <a:ln w="3175">
+            <a:solidFill>
+              <a:srgbClr val="E8E2DA"/>
+            </a:solidFill>
+            <a:prstDash val="solid"/>
+          </a:ln>
+        </p:spPr>
+      </p:sp>
+      <p:sp>
+        <p:nvSpPr>
+          <p:cNvPr id="114" name="Text 112"/>
+          <p:cNvSpPr/>
+          <p:nvPr/>
+        </p:nvSpPr>
+        <p:spPr>
+          <a:xfrm>
+            <a:off x="7955280" y="5559552"/>
             <a:ext cx="2286000" cy="329184"/>
           </a:xfrm>
           <a:prstGeom prst="rect">
@@ -8824,7 +9080,7 @@
                 <a:ea typeface="Georgia" pitchFamily="34" charset="-122"/>
                 <a:cs typeface="Georgia" pitchFamily="34" charset="-120"/>
               </a:rPr>
-              <a:t>Free</a:t>
+              <a:t>Starter</a:t>
             </a:r>
             <a:endParaRPr lang="en-US" sz="2200" dirty="0"/>
           </a:p>
@@ -8905,7 +9161,7 @@
                 <a:ea typeface="Calibri" pitchFamily="34" charset="-122"/>
                 <a:cs typeface="Calibri" pitchFamily="34" charset="-120"/>
               </a:rPr>
-              <a:t>Core features, 25 artworks, 3 viewing rooms. Perfect for getting started.</a:t>
+              <a:t>Core features, 25 artworks, 3 viewing rooms, 20 contacts. Perfect for getting started.</a:t>
             </a:r>
             <a:endParaRPr lang="en-US" sz="1100" dirty="0"/>
           </a:p>
@@ -9052,7 +9308,7 @@
                 <a:ea typeface="Calibri" pitchFamily="34" charset="-122"/>
                 <a:cs typeface="Calibri" pitchFamily="34" charset="-120"/>
               </a:rPr>
-              <a:t>Unlimited artworks, all features, analytics dashboard, priority support.</a:t>
+              <a:t>200 artworks, analytics, social scheduler, exhibitions, consignments — all features unlocked.</a:t>
             </a:r>
             <a:endParaRPr lang="en-US" sz="1100" dirty="0"/>
           </a:p>
@@ -9157,7 +9413,7 @@
                 <a:ea typeface="Georgia" pitchFamily="34" charset="-122"/>
                 <a:cs typeface="Georgia" pitchFamily="34" charset="-120"/>
               </a:rPr>
-              <a:t>$39/mo</a:t>
+              <a:t>$49/mo</a:t>
             </a:r>
             <a:endParaRPr lang="en-US" sz="3200" dirty="0"/>
           </a:p>
@@ -9199,7 +9455,7 @@
                 <a:ea typeface="Calibri" pitchFamily="34" charset="-122"/>
                 <a:cs typeface="Calibri" pitchFamily="34" charset="-120"/>
               </a:rPr>
-              <a:t>Everything in Pro + custom domain, white-label options, dedicated support.</a:t>
+              <a:t>Unlimited everything, custom domain, white-label options, dedicated support.</a:t>
             </a:r>
             <a:endParaRPr lang="en-US" sz="1100" dirty="0"/>
           </a:p>
@@ -9238,7 +9494,7 @@
                 <a:ea typeface="Calibri" pitchFamily="34" charset="-122"/>
                 <a:cs typeface="Calibri" pitchFamily="34" charset="-120"/>
               </a:rPr>
-              <a:t>Even our highest tier costs less than competitors’ cheapest plan.</a:t>
+              <a:t>Stripe payments built in. Even our highest tier costs less than competitors’ cheapest plan.</a:t>
             </a:r>
             <a:endParaRPr lang="en-US" sz="1200" dirty="0"/>
           </a:p>
@@ -9375,7 +9631,7 @@
                 <a:ea typeface="Georgia" pitchFamily="34" charset="-122"/>
                 <a:cs typeface="Georgia" pitchFamily="34" charset="-120"/>
               </a:rPr>
-              <a:t>23+</a:t>
+              <a:t>30+</a:t>
             </a:r>
             <a:endParaRPr lang="en-US" sz="3600" dirty="0"/>
           </a:p>
@@ -9480,7 +9736,7 @@
                 <a:ea typeface="Georgia" pitchFamily="34" charset="-122"/>
                 <a:cs typeface="Georgia" pitchFamily="34" charset="-120"/>
               </a:rPr>
-              <a:t>11</a:t>
+              <a:t>12</a:t>
             </a:r>
             <a:endParaRPr lang="en-US" sz="3600" dirty="0"/>
           </a:p>
@@ -9771,7 +10027,7 @@
                 <a:ea typeface="Calibri" pitchFamily="34" charset="-122"/>
                 <a:cs typeface="Calibri" pitchFamily="34" charset="-120"/>
               </a:rPr>
-              <a:t>MVP is fully functional with real data. Portfolio management, invoicing, viewing rooms, CRM, social scheduler, and 17 more features — all working end-to-end.</a:t>
+              <a:t>MVP is fully functional with real data. Stripe payments, plan gating, onboarding, portfolio management, invoicing, viewing rooms, CRM, and 22 more features — all working end-to-end.</a:t>
             </a:r>
             <a:endParaRPr lang="en-US" sz="1300" dirty="0"/>
           </a:p>
@@ -10571,7 +10827,7 @@
                 <a:ea typeface="Georgia" pitchFamily="34" charset="-122"/>
                 <a:cs typeface="Georgia" pitchFamily="34" charset="-120"/>
               </a:rPr>
-              <a:t>Row Level Security</a:t>
+              <a:t>Stripe</a:t>
             </a:r>
             <a:endParaRPr lang="en-US" sz="1600" dirty="0"/>
           </a:p>
@@ -10610,7 +10866,7 @@
                 <a:ea typeface="Calibri" pitchFamily="34" charset="-122"/>
                 <a:cs typeface="Calibri" pitchFamily="34" charset="-120"/>
               </a:rPr>
-              <a:t>Multi-tenant data isolation</a:t>
+              <a:t>Subscription payments, checkout, billing portal</a:t>
             </a:r>
             <a:endParaRPr lang="en-US" sz="1200" dirty="0"/>
           </a:p>

</xml_diff>